<commit_message>
feat(pramaan): complete master quant station with interactive command deck, curated theming, and FastAPI backend (PRM-VER-086 to PRM-VER-093)
</commit_message>
<xml_diff>
--- a/Pramaan_Presentation.pptx
+++ b/Pramaan_Presentation.pptx
@@ -3559,14 +3559,14 @@
           <a:p>
             <a:pPr algn="ctr"/>
             <a:r>
-              <a:rPr sz="1900">
+              <a:rPr sz="1700">
                 <a:solidFill>
                   <a:srgbClr val="FFFFFF"/>
                 </a:solidFill>
                 <a:latin typeface="Calibri"/>
               </a:rPr>
               <a:t>Under realistic Indian costs over 2019–2024, none of the four classic strategies beat passive ownership on a risk-adjusted basis.
-That is not a failure of the project. It is the result the engine was built to find.</a:t>
+Student Reflections (Syllabus 5.4): Zero-lookahead execution and statutory friction explain why over 90% of retail strategies fail live. An honest tool measures true worth.</a:t>
             </a:r>
           </a:p>
         </p:txBody>
@@ -3878,7 +3878,7 @@
                 </a:solidFill>
                 <a:latin typeface="Calibri"/>
               </a:rPr>
-              <a:t>GTU DI05000341 · Pramaan  ·  Apache 2.0  ·  Thank you</a:t>
+              <a:t>GTU DI05000341 · Pramaan · Aayush Bankar &amp; Meet Patel · Apache 2.0</a:t>
             </a:r>
           </a:p>
         </p:txBody>

</xml_diff>

<commit_message>
feat(packaging): Phase 4 - Tauri v2 desktop shell, landing page with cost calculator, README overhaul, and synchronized GTU report & slides (PRM-VER-106)
</commit_message>
<xml_diff>
--- a/Pramaan_Presentation.pptx
+++ b/Pramaan_Presentation.pptx
@@ -3751,7 +3751,7 @@
                 </a:solidFill>
                 <a:latin typeface="Calibri"/>
               </a:rPr>
-              <a:t>64%</a:t>
+              <a:t>60%</a:t>
             </a:r>
           </a:p>
           <a:p>
@@ -7187,20 +7187,20 @@
                 </a:solidFill>
                 <a:latin typeface="Calibri"/>
               </a:rPr>
-              <a:t>PBO = 64.3%</a:t>
+              <a:t>PBO = 60.0%</a:t>
             </a:r>
           </a:p>
           <a:p>
             <a:pPr algn="ctr"/>
             <a:r>
-              <a:rPr sz="1200">
+              <a:rPr sz="1100">
                 <a:solidFill>
                   <a:srgbClr val="CBD5E1"/>
                 </a:solidFill>
                 <a:latin typeface="Calibri"/>
               </a:rPr>
-              <a:t>probability the in-sample winner
-is not the out-of-sample winner</a:t>
+              <a:t>95% CI: [44.4%, 73.3%] · 133 configs · 45 paths
+probability in-sample winner underperforms OOS</a:t>
             </a:r>
           </a:p>
         </p:txBody>
@@ -7578,7 +7578,7 @@
                 </a:solidFill>
                 <a:latin typeface="Calibri"/>
               </a:rPr>
-              <a:t>35 automated tests</a:t>
+              <a:t>72 automated tests</a:t>
             </a:r>
           </a:p>
           <a:p>
@@ -7589,7 +7589,7 @@
                 </a:solidFill>
                 <a:latin typeface="Calibri"/>
               </a:rPr>
-              <a:t>up from 9 at baseline</a:t>
+              <a:t>up from 9 at baseline (100% offline via seeded fixtures)</a:t>
             </a:r>
           </a:p>
         </p:txBody>
@@ -7843,7 +7843,7 @@
                 </a:solidFill>
                 <a:latin typeface="Calibri"/>
               </a:rPr>
-              <a:t>▪  Reproduce everything with two commands:</a:t>
+              <a:t>▪  Reproduce everything with clean checkout commands:</a:t>
             </a:r>
           </a:p>
           <a:p>
@@ -7859,7 +7859,7 @@
                 </a:solidFill>
                 <a:latin typeface="Calibri"/>
               </a:rPr>
-              <a:t>PYTHONPATH=. python scripts/run_experiments.py</a:t>
+              <a:t>python scripts/run_experiments.py</a:t>
             </a:r>
           </a:p>
           <a:p>
@@ -7875,7 +7875,7 @@
                 </a:solidFill>
                 <a:latin typeface="Calibri"/>
               </a:rPr>
-              <a:t>PYTHONPATH=. python scripts/generate_real_charts.py</a:t>
+              <a:t>python scripts/generate_real_charts.py</a:t>
             </a:r>
           </a:p>
           <a:p>
@@ -7891,7 +7891,7 @@
                 </a:solidFill>
                 <a:latin typeface="Calibri"/>
               </a:rPr>
-              <a:t>Then: pytest tests/ -q  →  35 passed</a:t>
+              <a:t>Then: pytest tests/ -q  →  72 passed in ~7s</a:t>
             </a:r>
           </a:p>
         </p:txBody>

</xml_diff>